<commit_message>
deck/fig: behaviour fig uses representative seed (999, ~43% not seed-555's 25%); drop hotspot from next-steps
Co-Authored-By: Claude Opus 4.8 <noreply@anthropic.com>
</commit_message>
<xml_diff>
--- a/energy_saving_RL_project.pptx
+++ b/energy_saving_RL_project.pptx
@@ -3518,7 +3518,7 @@
                   <a:srgbClr val="666666"/>
                 </a:solidFill>
               </a:rPr>
-              <a:t>Power over time, # gNBs on, and which cell sleeps when. Idle cells sleep; busy cells stay on.</a:t>
+              <a:t>One shaped-RL run (seed 999, ~43% saved). RL's 4-seed AVERAGE is ~40% energy saved; per-seed it varies 25-46%. Idle cells sleep; busy cells stay on.</a:t>
             </a:r>
           </a:p>
         </p:txBody>
@@ -3569,7 +3569,7 @@
                   <a:srgbClr val="222222"/>
                 </a:solidFill>
               </a:rPr>
-              <a:t>Bottom line &amp; recommended next step</a:t>
+              <a:t>Bottom line &amp; next steps</a:t>
             </a:r>
           </a:p>
         </p:txBody>
@@ -3665,7 +3665,7 @@
                   <a:srgbClr val="666666"/>
                 </a:solidFill>
               </a:rPr>
-              <a:t>– a rigorous quantification of the energy-vs-QoS tradeoff, and a tunable energy-saving controller.</a:t>
+              <a:t>– a rigorous energy-vs-QoS tradeoff, and a tunable energy-saving controller.</a:t>
             </a:r>
           </a:p>
           <a:p>
@@ -3695,7 +3695,7 @@
                   <a:srgbClr val="666666"/>
                 </a:solidFill>
               </a:rPr>
-              <a:t>– (better on energy and dropped-calls; slightly lower throughput) - a favourable, honest tradeoff.</a:t>
+              <a:t>– - better on energy AND dropped-calls, slightly lower throughput: a favourable, honest tradeoff.</a:t>
             </a:r>
           </a:p>
           <a:p>
@@ -3710,7 +3710,22 @@
                   <a:srgbClr val="222222"/>
                 </a:solidFill>
               </a:rPr>
-              <a:t>• It does not STRICTLY beat a strong heuristic on all three axes - and we explain precisely why.</a:t>
+              <a:t>• It does not STRICTLY beat a strong heuristic on all three axes - the real blocker is the slow</a:t>
+            </a:r>
+          </a:p>
+          <a:p>
+            <a:pPr lvl="1">
+              <a:spcAft>
+                <a:spcPts val="700"/>
+              </a:spcAft>
+            </a:pPr>
+            <a:r>
+              <a:rPr sz="1500">
+                <a:solidFill>
+                  <a:srgbClr val="666666"/>
+                </a:solidFill>
+              </a:rPr>
+              <a:t>– simulator's tiny sample budget (~640 RL trial-steps), too little to out-tune a good heuristic.</a:t>
             </a:r>
           </a:p>
           <a:p>
@@ -3725,7 +3740,7 @@
                   <a:srgbClr val="222222"/>
                 </a:solidFill>
               </a:rPr>
-              <a:t>• Next step for a strict win: a spatial-HOTSPOT scenario (some cells persistently idle), where a smart</a:t>
+              <a:t>• Next steps: (1) sample-efficient RL - offline RL on logged data, or a fast learned surrogate of the</a:t>
             </a:r>
           </a:p>
           <a:p>
@@ -3740,7 +3755,7 @@
                   <a:srgbClr val="666666"/>
                 </a:solidFill>
               </a:rPr>
-              <a:t>– controller can sleep truly-unused cells for free - more realistic and genuinely winnable.</a:t>
+              <a:t>– sim - to escape that budget;  (2) richer / larger network scenarios;  (3) ship the tunable controller.</a:t>
             </a:r>
           </a:p>
         </p:txBody>

</xml_diff>

<commit_message>
deck: merge hard-wrapped sentence fragments into whole bullets
The old flat deck manually split sentences across a level-0 line + a level-1
sub-bullet to control width. With auto-wrapping panels those splits rendered as
orphaned dashed fragments (worst on slide 12). Merged each split back into one
bullet on slides 2/3/6/9/12/13 (wording unchanged) and added bold lead-in labels
on the bottom-line slide. Genuine sub-steps (slide 4) kept as-is.
</commit_message>
<xml_diff>
--- a/energy_saving_RL_project.pptx
+++ b/energy_saving_RL_project.pptx
@@ -4749,7 +4749,7 @@
               </a:spcAft>
             </a:pPr>
             <a:r>
-              <a:rPr sz="1600" b="1" i="0">
+              <a:rPr sz="1800" b="1" i="0">
                 <a:solidFill>
                   <a:srgbClr val="0072B2"/>
                 </a:solidFill>
@@ -4757,38 +4757,20 @@
               <a:t>▪  </a:t>
             </a:r>
             <a:r>
-              <a:rPr sz="1600" b="0" i="0">
+              <a:rPr sz="1800" b="1" i="0">
                 <a:solidFill>
                   <a:srgbClr val="1A2233"/>
                 </a:solidFill>
               </a:rPr>
-              <a:t>Delivered: a realistic bursty twin, a working imitation+RL pipeline (BC 100% match, stable PPO),</a:t>
-            </a:r>
-          </a:p>
-          <a:p>
-            <a:pPr marL="603504" indent="-274320">
-              <a:lnSpc>
-                <a:spcPct val="112000"/>
-              </a:lnSpc>
-              <a:spcAft>
-                <a:spcPts val="500"/>
-              </a:spcAft>
-            </a:pPr>
-            <a:r>
-              <a:rPr sz="1400" b="1" i="0">
-                <a:solidFill>
-                  <a:srgbClr val="009E73"/>
-                </a:solidFill>
-              </a:rPr>
-              <a:t>–  </a:t>
-            </a:r>
-            <a:r>
-              <a:rPr sz="1400" b="0" i="0">
-                <a:solidFill>
-                  <a:srgbClr val="5B6472"/>
-                </a:solidFill>
-              </a:rPr>
-              <a:t>a rigorous energy-vs-QoS tradeoff, and a tunable energy-saving controller.</a:t>
+              <a:t>Delivered:</a:t>
+            </a:r>
+            <a:r>
+              <a:rPr sz="1800" b="0" i="0">
+                <a:solidFill>
+                  <a:srgbClr val="1A2233"/>
+                </a:solidFill>
+              </a:rPr>
+              <a:t> a realistic bursty twin, a working imitation+RL pipeline (BC 100% match, stable PPO), a rigorous energy-vs-QoS tradeoff, and a tunable energy-saving controller.</a:t>
             </a:r>
           </a:p>
           <a:p>
@@ -4801,7 +4783,7 @@
               </a:spcAft>
             </a:pPr>
             <a:r>
-              <a:rPr sz="1600" b="1" i="0">
+              <a:rPr sz="1800" b="1" i="0">
                 <a:solidFill>
                   <a:srgbClr val="0072B2"/>
                 </a:solidFill>
@@ -4809,38 +4791,20 @@
               <a:t>▪  </a:t>
             </a:r>
             <a:r>
-              <a:rPr sz="1600" b="0" i="0">
+              <a:rPr sz="1800" b="1" i="0">
                 <a:solidFill>
                   <a:srgbClr val="1A2233"/>
                 </a:solidFill>
               </a:rPr>
-              <a:t>RL result: with reward shaping, RL learns a greener + more-reliable operating point than the heuristic</a:t>
-            </a:r>
-          </a:p>
-          <a:p>
-            <a:pPr marL="603504" indent="-274320">
-              <a:lnSpc>
-                <a:spcPct val="112000"/>
-              </a:lnSpc>
-              <a:spcAft>
-                <a:spcPts val="500"/>
-              </a:spcAft>
-            </a:pPr>
-            <a:r>
-              <a:rPr sz="1400" b="1" i="0">
-                <a:solidFill>
-                  <a:srgbClr val="009E73"/>
-                </a:solidFill>
-              </a:rPr>
-              <a:t>–  </a:t>
-            </a:r>
-            <a:r>
-              <a:rPr sz="1400" b="0" i="0">
-                <a:solidFill>
-                  <a:srgbClr val="5B6472"/>
-                </a:solidFill>
-              </a:rPr>
-              <a:t>- better on energy AND dropped-calls, slightly lower throughput: a favourable, honest tradeoff.</a:t>
+              <a:t>RL result:</a:t>
+            </a:r>
+            <a:r>
+              <a:rPr sz="1800" b="0" i="0">
+                <a:solidFill>
+                  <a:srgbClr val="1A2233"/>
+                </a:solidFill>
+              </a:rPr>
+              <a:t> with reward shaping, RL learns a greener + more-reliable operating point than the heuristic - better on energy AND dropped-calls, slightly lower throughput: a favourable, honest tradeoff.</a:t>
             </a:r>
           </a:p>
           <a:p>
@@ -4853,7 +4817,7 @@
               </a:spcAft>
             </a:pPr>
             <a:r>
-              <a:rPr sz="1600" b="1" i="0">
+              <a:rPr sz="1800" b="1" i="0">
                 <a:solidFill>
                   <a:srgbClr val="0072B2"/>
                 </a:solidFill>
@@ -4861,38 +4825,20 @@
               <a:t>▪  </a:t>
             </a:r>
             <a:r>
-              <a:rPr sz="1600" b="0" i="0">
+              <a:rPr sz="1800" b="1" i="0">
                 <a:solidFill>
                   <a:srgbClr val="1A2233"/>
                 </a:solidFill>
               </a:rPr>
-              <a:t>It does not STRICTLY beat a strong heuristic on all three axes - the real blocker is the slow</a:t>
-            </a:r>
-          </a:p>
-          <a:p>
-            <a:pPr marL="603504" indent="-274320">
-              <a:lnSpc>
-                <a:spcPct val="112000"/>
-              </a:lnSpc>
-              <a:spcAft>
-                <a:spcPts val="500"/>
-              </a:spcAft>
-            </a:pPr>
-            <a:r>
-              <a:rPr sz="1400" b="1" i="0">
-                <a:solidFill>
-                  <a:srgbClr val="009E73"/>
-                </a:solidFill>
-              </a:rPr>
-              <a:t>–  </a:t>
-            </a:r>
-            <a:r>
-              <a:rPr sz="1400" b="0" i="0">
-                <a:solidFill>
-                  <a:srgbClr val="5B6472"/>
-                </a:solidFill>
-              </a:rPr>
-              <a:t>simulator's tiny sample budget (~640 RL trial-steps), too little to out-tune a good heuristic.</a:t>
+              <a:t>It does not STRICTLY beat</a:t>
+            </a:r>
+            <a:r>
+              <a:rPr sz="1800" b="0" i="0">
+                <a:solidFill>
+                  <a:srgbClr val="1A2233"/>
+                </a:solidFill>
+              </a:rPr>
+              <a:t> a strong heuristic on all three axes - the real blocker is the slow simulator's tiny sample budget (~640 RL trial-steps), too little to out-tune a good heuristic.</a:t>
             </a:r>
           </a:p>
           <a:p>
@@ -4905,7 +4851,7 @@
               </a:spcAft>
             </a:pPr>
             <a:r>
-              <a:rPr sz="1600" b="1" i="0">
+              <a:rPr sz="1800" b="1" i="0">
                 <a:solidFill>
                   <a:srgbClr val="0072B2"/>
                 </a:solidFill>
@@ -4913,38 +4859,20 @@
               <a:t>▪  </a:t>
             </a:r>
             <a:r>
-              <a:rPr sz="1600" b="0" i="0">
+              <a:rPr sz="1800" b="1" i="0">
                 <a:solidFill>
                   <a:srgbClr val="1A2233"/>
                 </a:solidFill>
               </a:rPr>
-              <a:t>Next steps: (1) sample-efficient RL - offline RL on logged data, or a fast learned surrogate of the</a:t>
-            </a:r>
-          </a:p>
-          <a:p>
-            <a:pPr marL="603504" indent="-274320">
-              <a:lnSpc>
-                <a:spcPct val="112000"/>
-              </a:lnSpc>
-              <a:spcAft>
-                <a:spcPts val="500"/>
-              </a:spcAft>
-            </a:pPr>
-            <a:r>
-              <a:rPr sz="1400" b="1" i="0">
-                <a:solidFill>
-                  <a:srgbClr val="009E73"/>
-                </a:solidFill>
-              </a:rPr>
-              <a:t>–  </a:t>
-            </a:r>
-            <a:r>
-              <a:rPr sz="1400" b="0" i="0">
-                <a:solidFill>
-                  <a:srgbClr val="5B6472"/>
-                </a:solidFill>
-              </a:rPr>
-              <a:t>sim - to escape that budget;  (2) richer / larger network scenarios;  (3) ship the tunable controller.</a:t>
+              <a:t>Next steps:</a:t>
+            </a:r>
+            <a:r>
+              <a:rPr sz="1800" b="0" i="0">
+                <a:solidFill>
+                  <a:srgbClr val="1A2233"/>
+                </a:solidFill>
+              </a:rPr>
+              <a:t> (1) sample-efficient RL - offline RL on logged data, or a fast learned surrogate of the sim - to escape that budget;  (2) richer / larger network scenarios;  (3) ship the tunable controller.</a:t>
             </a:r>
           </a:p>
         </p:txBody>
@@ -5395,33 +5323,7 @@
                   <a:srgbClr val="1A2233"/>
                 </a:solidFill>
               </a:rPr>
-              <a:t>Docs (self-contained): OVERVIEW.md (how it all works), RESULTS.md (findings &amp; numbers),</a:t>
-            </a:r>
-          </a:p>
-          <a:p>
-            <a:pPr marL="603504" indent="-274320">
-              <a:lnSpc>
-                <a:spcPct val="112000"/>
-              </a:lnSpc>
-              <a:spcAft>
-                <a:spcPts val="500"/>
-              </a:spcAft>
-            </a:pPr>
-            <a:r>
-              <a:rPr sz="1600" b="1" i="0">
-                <a:solidFill>
-                  <a:srgbClr val="009E73"/>
-                </a:solidFill>
-              </a:rPr>
-              <a:t>–  </a:t>
-            </a:r>
-            <a:r>
-              <a:rPr sz="1600" b="0" i="0">
-                <a:solidFill>
-                  <a:srgbClr val="5B6472"/>
-                </a:solidFill>
-              </a:rPr>
-              <a:t>REPRODUCE.md (build &amp; run from scratch), CONTEXT.md (full-journey primer).</a:t>
+              <a:t>Docs (self-contained): OVERVIEW.md (how it all works), RESULTS.md (findings &amp; numbers), REPRODUCE.md (build &amp; run from scratch), CONTEXT.md (full-journey primer).</a:t>
             </a:r>
           </a:p>
           <a:p>
@@ -5924,33 +5826,7 @@
                   <a:srgbClr val="1A2233"/>
                 </a:solidFill>
               </a:rPr>
-              <a:t>Company goal: a reinforcement-learning (RL) controller that beats the hand-coded heuristic on the</a:t>
-            </a:r>
-          </a:p>
-          <a:p>
-            <a:pPr marL="603504" indent="-274320">
-              <a:lnSpc>
-                <a:spcPct val="112000"/>
-              </a:lnSpc>
-              <a:spcAft>
-                <a:spcPts val="500"/>
-              </a:spcAft>
-            </a:pPr>
-            <a:r>
-              <a:rPr sz="1600" b="1" i="0">
-                <a:solidFill>
-                  <a:srgbClr val="009E73"/>
-                </a:solidFill>
-              </a:rPr>
-              <a:t>–  </a:t>
-            </a:r>
-            <a:r>
-              <a:rPr sz="1600" b="0" i="0">
-                <a:solidFill>
-                  <a:srgbClr val="5B6472"/>
-                </a:solidFill>
-              </a:rPr>
-              <a:t>energy-vs-QoS tradeoff — more energy saved without hurting throughput or reliability.</a:t>
+              <a:t>Company goal: a reinforcement-learning (RL) controller that beats the hand-coded heuristic on the energy-vs-QoS tradeoff — more energy saved without hurting throughput or reliability.</a:t>
             </a:r>
           </a:p>
         </p:txBody>
@@ -6375,33 +6251,7 @@
                   <a:srgbClr val="1A2233"/>
                 </a:solidFill>
               </a:rPr>
-              <a:t>Traffic redesigned to 3 sharp bursts per episode (+ an always-on baseline user) — so the controller</a:t>
-            </a:r>
-          </a:p>
-          <a:p>
-            <a:pPr marL="603504" indent="-274320">
-              <a:lnSpc>
-                <a:spcPct val="112000"/>
-              </a:lnSpc>
-              <a:spcAft>
-                <a:spcPts val="500"/>
-              </a:spcAft>
-            </a:pPr>
-            <a:r>
-              <a:rPr sz="1600" b="1" i="0">
-                <a:solidFill>
-                  <a:srgbClr val="009E73"/>
-                </a:solidFill>
-              </a:rPr>
-              <a:t>–  </a:t>
-            </a:r>
-            <a:r>
-              <a:rPr sz="1600" b="0" i="0">
-                <a:solidFill>
-                  <a:srgbClr val="5B6472"/>
-                </a:solidFill>
-              </a:rPr>
-              <a:t>must adapt in real time (sleep in the lulls, wake for the bursts).</a:t>
+              <a:t>Traffic redesigned to 3 sharp bursts per episode (+ an always-on baseline user) — so the controller must adapt in real time (sleep in the lulls, wake for the bursts).</a:t>
             </a:r>
           </a:p>
           <a:p>
@@ -7910,33 +7760,7 @@
                   <a:srgbClr val="1A2233"/>
                 </a:solidFill>
               </a:rPr>
-              <a:t>2)  Behaviour Cloning (+ critic warm-up) - clone the heuristic into the policy AND pre-train its value</a:t>
-            </a:r>
-          </a:p>
-          <a:p>
-            <a:pPr marL="603504" indent="-274320">
-              <a:lnSpc>
-                <a:spcPct val="112000"/>
-              </a:lnSpc>
-              <a:spcAft>
-                <a:spcPts val="500"/>
-              </a:spcAft>
-            </a:pPr>
-            <a:r>
-              <a:rPr sz="1600" b="1" i="0">
-                <a:solidFill>
-                  <a:srgbClr val="009E73"/>
-                </a:solidFill>
-              </a:rPr>
-              <a:t>–  </a:t>
-            </a:r>
-            <a:r>
-              <a:rPr sz="1600" b="0" i="0">
-                <a:solidFill>
-                  <a:srgbClr val="5B6472"/>
-                </a:solidFill>
-              </a:rPr>
-              <a:t>estimator; the warm-up fixes a classic BC-&gt;PPO collapse we hit and diagnosed.</a:t>
+              <a:t>2)  Behaviour Cloning (+ critic warm-up) - clone the heuristic into the policy AND pre-train its value estimator; the warm-up fixes a classic BC-&gt;PPO collapse we hit and diagnosed.</a:t>
             </a:r>
           </a:p>
           <a:p>
@@ -9321,33 +9145,7 @@
                   <a:srgbClr val="1A2233"/>
                 </a:solidFill>
               </a:rPr>
-              <a:t>RL is sample-starved: the slow sim affords only ~640 trial-steps, and random on/off exploration</a:t>
-            </a:r>
-          </a:p>
-          <a:p>
-            <a:pPr marL="603504" indent="-274320">
-              <a:lnSpc>
-                <a:spcPct val="112000"/>
-              </a:lnSpc>
-              <a:spcAft>
-                <a:spcPts val="500"/>
-              </a:spcAft>
-            </a:pPr>
-            <a:r>
-              <a:rPr sz="1600" b="1" i="0">
-                <a:solidFill>
-                  <a:srgbClr val="009E73"/>
-                </a:solidFill>
-              </a:rPr>
-              <a:t>–  </a:t>
-            </a:r>
-            <a:r>
-              <a:rPr sz="1600" b="0" i="0">
-                <a:solidFill>
-                  <a:srgbClr val="5B6472"/>
-                </a:solidFill>
-              </a:rPr>
-              <a:t>sleeps idle AND busy cells together -&gt; can't isolate 'sleeping THIS idle cell was the good move'.</a:t>
+              <a:t>RL is sample-starved: the slow sim affords only ~640 trial-steps, and random on/off exploration sleeps idle AND busy cells together -&gt; can't isolate 'sleeping THIS idle cell was the good move'.</a:t>
             </a:r>
           </a:p>
           <a:p>
@@ -9373,33 +9171,7 @@
                   <a:srgbClr val="1A2233"/>
                 </a:solidFill>
               </a:rPr>
-              <a:t>The 43% 'idle-but-powered' waste is real in hindsight, but NOT free to reclaim: sleeping a</a:t>
-            </a:r>
-          </a:p>
-          <a:p>
-            <a:pPr marL="603504" indent="-274320">
-              <a:lnSpc>
-                <a:spcPct val="112000"/>
-              </a:lnSpc>
-              <a:spcAft>
-                <a:spcPts val="500"/>
-              </a:spcAft>
-            </a:pPr>
-            <a:r>
-              <a:rPr sz="1600" b="1" i="0">
-                <a:solidFill>
-                  <a:srgbClr val="009E73"/>
-                </a:solidFill>
-              </a:rPr>
-              <a:t>–  </a:t>
-            </a:r>
-            <a:r>
-              <a:rPr sz="1600" b="0" i="0">
-                <a:solidFill>
-                  <a:srgbClr val="5B6472"/>
-                </a:solidFill>
-              </a:rPr>
-              <a:t>momentarily-idle cell that's needed next causes a dropped call. The heuristic's caution is justified.</a:t>
+              <a:t>The 43% 'idle-but-powered' waste is real in hindsight, but NOT free to reclaim: sleeping a momentarily-idle cell that's needed next causes a dropped call. The heuristic's caution is justified.</a:t>
             </a:r>
           </a:p>
           <a:p>

</xml_diff>